<commit_message>
Update response time and data distributions
</commit_message>
<xml_diff>
--- a/Documentation/Latency and Response Time.pptx
+++ b/Documentation/Latency and Response Time.pptx
@@ -104,6 +104,11 @@
       </a:defRPr>
     </a:lvl9pPr>
   </p:defaultTextStyle>
+  <p:extLst>
+    <p:ext uri="{EFAFB233-063F-42B5-8137-9DF3F51BA10A}">
+      <p15:sldGuideLst xmlns:p15="http://schemas.microsoft.com/office/powerpoint/2012/main"/>
+    </p:ext>
+  </p:extLst>
 </p:presentation>
 </file>
 
@@ -254,7 +259,7 @@
           <a:p>
             <a:fld id="{2231E127-0FFC-443A-B14E-CEAC92C6D946}" type="datetimeFigureOut">
               <a:rPr lang="en-US" smtClean="0"/>
-              <a:t>3/19/2023</a:t>
+              <a:t>3/27/23</a:t>
             </a:fld>
             <a:endParaRPr lang="en-US"/>
           </a:p>
@@ -452,7 +457,7 @@
           <a:p>
             <a:fld id="{2231E127-0FFC-443A-B14E-CEAC92C6D946}" type="datetimeFigureOut">
               <a:rPr lang="en-US" smtClean="0"/>
-              <a:t>3/19/2023</a:t>
+              <a:t>3/27/23</a:t>
             </a:fld>
             <a:endParaRPr lang="en-US"/>
           </a:p>
@@ -660,7 +665,7 @@
           <a:p>
             <a:fld id="{2231E127-0FFC-443A-B14E-CEAC92C6D946}" type="datetimeFigureOut">
               <a:rPr lang="en-US" smtClean="0"/>
-              <a:t>3/19/2023</a:t>
+              <a:t>3/27/23</a:t>
             </a:fld>
             <a:endParaRPr lang="en-US"/>
           </a:p>
@@ -858,7 +863,7 @@
           <a:p>
             <a:fld id="{2231E127-0FFC-443A-B14E-CEAC92C6D946}" type="datetimeFigureOut">
               <a:rPr lang="en-US" smtClean="0"/>
-              <a:t>3/19/2023</a:t>
+              <a:t>3/27/23</a:t>
             </a:fld>
             <a:endParaRPr lang="en-US"/>
           </a:p>
@@ -1133,7 +1138,7 @@
           <a:p>
             <a:fld id="{2231E127-0FFC-443A-B14E-CEAC92C6D946}" type="datetimeFigureOut">
               <a:rPr lang="en-US" smtClean="0"/>
-              <a:t>3/19/2023</a:t>
+              <a:t>3/27/23</a:t>
             </a:fld>
             <a:endParaRPr lang="en-US"/>
           </a:p>
@@ -1398,7 +1403,7 @@
           <a:p>
             <a:fld id="{2231E127-0FFC-443A-B14E-CEAC92C6D946}" type="datetimeFigureOut">
               <a:rPr lang="en-US" smtClean="0"/>
-              <a:t>3/19/2023</a:t>
+              <a:t>3/27/23</a:t>
             </a:fld>
             <a:endParaRPr lang="en-US"/>
           </a:p>
@@ -1810,7 +1815,7 @@
           <a:p>
             <a:fld id="{2231E127-0FFC-443A-B14E-CEAC92C6D946}" type="datetimeFigureOut">
               <a:rPr lang="en-US" smtClean="0"/>
-              <a:t>3/19/2023</a:t>
+              <a:t>3/27/23</a:t>
             </a:fld>
             <a:endParaRPr lang="en-US"/>
           </a:p>
@@ -1951,7 +1956,7 @@
           <a:p>
             <a:fld id="{2231E127-0FFC-443A-B14E-CEAC92C6D946}" type="datetimeFigureOut">
               <a:rPr lang="en-US" smtClean="0"/>
-              <a:t>3/19/2023</a:t>
+              <a:t>3/27/23</a:t>
             </a:fld>
             <a:endParaRPr lang="en-US"/>
           </a:p>
@@ -2064,7 +2069,7 @@
           <a:p>
             <a:fld id="{2231E127-0FFC-443A-B14E-CEAC92C6D946}" type="datetimeFigureOut">
               <a:rPr lang="en-US" smtClean="0"/>
-              <a:t>3/19/2023</a:t>
+              <a:t>3/27/23</a:t>
             </a:fld>
             <a:endParaRPr lang="en-US"/>
           </a:p>
@@ -2375,7 +2380,7 @@
           <a:p>
             <a:fld id="{2231E127-0FFC-443A-B14E-CEAC92C6D946}" type="datetimeFigureOut">
               <a:rPr lang="en-US" smtClean="0"/>
-              <a:t>3/19/2023</a:t>
+              <a:t>3/27/23</a:t>
             </a:fld>
             <a:endParaRPr lang="en-US"/>
           </a:p>
@@ -2663,7 +2668,7 @@
           <a:p>
             <a:fld id="{2231E127-0FFC-443A-B14E-CEAC92C6D946}" type="datetimeFigureOut">
               <a:rPr lang="en-US" smtClean="0"/>
-              <a:t>3/19/2023</a:t>
+              <a:t>3/27/23</a:t>
             </a:fld>
             <a:endParaRPr lang="en-US"/>
           </a:p>
@@ -2904,7 +2909,7 @@
           <a:p>
             <a:fld id="{2231E127-0FFC-443A-B14E-CEAC92C6D946}" type="datetimeFigureOut">
               <a:rPr lang="en-US" smtClean="0"/>
-              <a:t>3/19/2023</a:t>
+              <a:t>3/27/23</a:t>
             </a:fld>
             <a:endParaRPr lang="en-US"/>
           </a:p>
@@ -4329,10 +4334,10 @@
         </p:nvGrpSpPr>
         <p:grpSpPr>
           <a:xfrm>
-            <a:off x="1660535" y="3590587"/>
-            <a:ext cx="2310242" cy="701648"/>
-            <a:chOff x="3225518" y="5649770"/>
-            <a:chExt cx="6083995" cy="701648"/>
+            <a:off x="1660535" y="3624040"/>
+            <a:ext cx="2310242" cy="668195"/>
+            <a:chOff x="3225518" y="5683223"/>
+            <a:chExt cx="6083995" cy="668195"/>
           </a:xfrm>
         </p:grpSpPr>
         <p:cxnSp>
@@ -4391,8 +4396,8 @@
           </p:nvSpPr>
           <p:spPr>
             <a:xfrm>
-              <a:off x="3831942" y="5649770"/>
-              <a:ext cx="4754621" cy="646331"/>
+              <a:off x="3544562" y="5683223"/>
+              <a:ext cx="5329377" cy="646331"/>
             </a:xfrm>
             <a:prstGeom prst="rect">
               <a:avLst/>
@@ -4408,14 +4413,14 @@
               <a:pPr algn="ctr"/>
               <a:r>
                 <a:rPr lang="en-US" dirty="0"/>
-                <a:t>Round Trip Latency </a:t>
+                <a:t>Client Side</a:t>
               </a:r>
             </a:p>
             <a:p>
               <a:pPr algn="ctr"/>
               <a:r>
                 <a:rPr lang="en-US" dirty="0"/>
-                <a:t>Client Side</a:t>
+                <a:t>Round Trip Latency </a:t>
               </a:r>
             </a:p>
           </p:txBody>
@@ -4736,8 +4741,8 @@
           </p:nvSpPr>
           <p:spPr>
             <a:xfrm>
-              <a:off x="5255303" y="5971042"/>
-              <a:ext cx="1907908" cy="369332"/>
+              <a:off x="4743570" y="5971042"/>
+              <a:ext cx="2931375" cy="369332"/>
             </a:xfrm>
             <a:prstGeom prst="rect">
               <a:avLst/>
@@ -4753,7 +4758,7 @@
               <a:pPr algn="ctr"/>
               <a:r>
                 <a:rPr lang="en-US" dirty="0"/>
-                <a:t>Internal Processing Time</a:t>
+                <a:t>Middleware-Databases Response Time</a:t>
               </a:r>
             </a:p>
           </p:txBody>
@@ -4905,6 +4910,105 @@
           </a:fontRef>
         </p:style>
       </p:cxnSp>
+      <p:grpSp>
+        <p:nvGrpSpPr>
+          <p:cNvPr id="2" name="Group 1">
+            <a:extLst>
+              <a:ext uri="{FF2B5EF4-FFF2-40B4-BE49-F238E27FC236}">
+                <a16:creationId xmlns:a16="http://schemas.microsoft.com/office/drawing/2014/main" id="{DB402A56-0988-A3E5-2045-59165472C1B8}"/>
+              </a:ext>
+            </a:extLst>
+          </p:cNvPr>
+          <p:cNvGrpSpPr/>
+          <p:nvPr/>
+        </p:nvGrpSpPr>
+        <p:grpSpPr>
+          <a:xfrm>
+            <a:off x="3965607" y="4170820"/>
+            <a:ext cx="3841169" cy="404631"/>
+            <a:chOff x="-621078" y="5980364"/>
+            <a:chExt cx="10868544" cy="404631"/>
+          </a:xfrm>
+        </p:grpSpPr>
+        <p:cxnSp>
+          <p:nvCxnSpPr>
+            <p:cNvPr id="3" name="Straight Arrow Connector 2">
+              <a:extLst>
+                <a:ext uri="{FF2B5EF4-FFF2-40B4-BE49-F238E27FC236}">
+                  <a16:creationId xmlns:a16="http://schemas.microsoft.com/office/drawing/2014/main" id="{92A86BE6-3A6D-0E10-F3D2-6983E617FED0}"/>
+                </a:ext>
+              </a:extLst>
+            </p:cNvPr>
+            <p:cNvCxnSpPr>
+              <a:cxnSpLocks/>
+            </p:cNvCxnSpPr>
+            <p:nvPr/>
+          </p:nvCxnSpPr>
+          <p:spPr>
+            <a:xfrm flipV="1">
+              <a:off x="-621078" y="6357445"/>
+              <a:ext cx="10868544" cy="27550"/>
+            </a:xfrm>
+            <a:prstGeom prst="straightConnector1">
+              <a:avLst/>
+            </a:prstGeom>
+            <a:ln w="28575">
+              <a:headEnd type="triangle"/>
+              <a:tailEnd type="triangle"/>
+            </a:ln>
+          </p:spPr>
+          <p:style>
+            <a:lnRef idx="3">
+              <a:schemeClr val="dk1"/>
+            </a:lnRef>
+            <a:fillRef idx="0">
+              <a:schemeClr val="dk1"/>
+            </a:fillRef>
+            <a:effectRef idx="2">
+              <a:schemeClr val="dk1"/>
+            </a:effectRef>
+            <a:fontRef idx="minor">
+              <a:schemeClr val="tx1"/>
+            </a:fontRef>
+          </p:style>
+        </p:cxnSp>
+        <p:sp>
+          <p:nvSpPr>
+            <p:cNvPr id="4" name="TextBox 3">
+              <a:extLst>
+                <a:ext uri="{FF2B5EF4-FFF2-40B4-BE49-F238E27FC236}">
+                  <a16:creationId xmlns:a16="http://schemas.microsoft.com/office/drawing/2014/main" id="{084515F6-A185-A79A-CBC7-1FE229486569}"/>
+                </a:ext>
+              </a:extLst>
+            </p:cNvPr>
+            <p:cNvSpPr txBox="1"/>
+            <p:nvPr/>
+          </p:nvSpPr>
+          <p:spPr>
+            <a:xfrm>
+              <a:off x="1294687" y="5980364"/>
+              <a:ext cx="7021232" cy="369332"/>
+            </a:xfrm>
+            <a:prstGeom prst="rect">
+              <a:avLst/>
+            </a:prstGeom>
+            <a:noFill/>
+          </p:spPr>
+          <p:txBody>
+            <a:bodyPr wrap="none" rtlCol="0">
+              <a:spAutoFit/>
+            </a:bodyPr>
+            <a:lstStyle/>
+            <a:p>
+              <a:pPr algn="ctr"/>
+              <a:r>
+                <a:rPr lang="en-US" dirty="0"/>
+                <a:t>Internal Processing Time</a:t>
+              </a:r>
+            </a:p>
+          </p:txBody>
+        </p:sp>
+      </p:grpSp>
     </p:spTree>
     <p:extLst>
       <p:ext uri="{BB962C8B-B14F-4D97-AF65-F5344CB8AC3E}">

</xml_diff>